<commit_message>
Strengthen team stand-out narrative with real track record
Replace generic prior-work claims with verifiable hackathon results
(NitroStack x Amrita 2026, HackHazards '26) and concrete prior builds
(Food Rescue, HaemNet, PrivaSafe, RiskLens/VolGraph). Adds a dedicated
"Why Us" slide to the deck and rewrites the submission form's
prior-builds and stand-out sections to match.

Co-Authored-By: Claude Sonnet 5 <noreply@anthropic.com>
Claude-Session: https://claude.ai/code/session_017oB1CyggkK1qow9rdviwQ9
</commit_message>
<xml_diff>
--- a/docs/VaidyaVani_Deck.pptx
+++ b/docs/VaidyaVani_Deck.pptx
@@ -15,9 +15,10 @@
     <p:sldId id="263" r:id="rId9"/>
     <p:sldId id="264" r:id="rId10"/>
     <p:sldId id="265" r:id="rId11"/>
+    <p:sldId id="266" r:id="rId12"/>
   </p:sldIdLst>
   <p:notesMasterIdLst>
-    <p:notesMasterId r:id="rId12"/>
+    <p:notesMasterId r:id="rId13"/>
   </p:notesMasterIdLst>
   <p:sldSz cx="12192000" cy="6858000"/>
   <p:notesSz cx="6858000" cy="12192000"/>
@@ -623,6 +624,94 @@
             <a:fld id="{F7021451-1387-4CA6-816F-3879F97B5CBC}" type="slidenum">
               <a:rPr lang="en-US"/>
               <a:t>10</a:t>
+            </a:fld>
+            <a:endParaRPr lang="en-US"/>
+          </a:p>
+        </p:txBody>
+      </p:sp>
+    </p:spTree>
+    <p:extLst>
+      <p:ext uri="{BB962C8B-B14F-4D97-AF65-F5344CB8AC3E}">
+        <p14:creationId xmlns:p14="http://schemas.microsoft.com/office/powerpoint/2010/main" val="1024086991"/>
+      </p:ext>
+    </p:extLst>
+  </p:cSld>
+  <p:clrMapOvr>
+    <a:masterClrMapping/>
+  </p:clrMapOvr>
+</p:notes>
+</file>
+
+<file path=ppt/notesSlides/notesSlide11.xml><?xml version="1.0" encoding="utf-8"?>
+<p:notes xmlns:a="http://schemas.openxmlformats.org/drawingml/2006/main" xmlns:r="http://schemas.openxmlformats.org/officeDocument/2006/relationships" xmlns:p="http://schemas.openxmlformats.org/presentationml/2006/main">
+  <p:cSld>
+    <p:spTree>
+      <p:nvGrpSpPr>
+        <p:cNvPr id="1" name=""/>
+        <p:cNvGrpSpPr/>
+        <p:nvPr/>
+      </p:nvGrpSpPr>
+      <p:grpSpPr>
+        <a:xfrm>
+          <a:off x="0" y="0"/>
+          <a:ext cx="0" cy="0"/>
+          <a:chOff x="0" y="0"/>
+          <a:chExt cx="0" cy="0"/>
+        </a:xfrm>
+      </p:grpSpPr>
+      <p:sp>
+        <p:nvSpPr>
+          <p:cNvPr id="2" name="Slide Image Placeholder 1"/>
+          <p:cNvSpPr>
+            <a:spLocks noGrp="1" noRot="1" noChangeAspect="1"/>
+          </p:cNvSpPr>
+          <p:nvPr>
+            <p:ph type="sldImg"/>
+          </p:nvPr>
+        </p:nvSpPr>
+        <p:spPr/>
+      </p:sp>
+      <p:sp>
+        <p:nvSpPr>
+          <p:cNvPr id="3" name="Notes Placeholder 2"/>
+          <p:cNvSpPr>
+            <a:spLocks noGrp="1"/>
+          </p:cNvSpPr>
+          <p:nvPr>
+            <p:ph type="body" idx="1"/>
+          </p:nvPr>
+        </p:nvSpPr>
+        <p:spPr/>
+        <p:txBody>
+          <a:bodyPr/>
+          <a:lstStyle/>
+          <a:p>
+            <a:r>
+              <a:rPr lang="en-US" dirty="0"/>
+              <a:t/>
+            </a:r>
+            <a:endParaRPr lang="en-US" dirty="0"/>
+          </a:p>
+        </p:txBody>
+      </p:sp>
+      <p:sp>
+        <p:nvSpPr>
+          <p:cNvPr id="4" name="Slide Number Placeholder 3"/>
+          <p:cNvSpPr>
+            <a:spLocks noGrp="1"/>
+          </p:cNvSpPr>
+          <p:nvPr>
+            <p:ph type="sldNum" sz="quarter" idx="10"/>
+          </p:nvPr>
+        </p:nvSpPr>
+        <p:spPr/>
+        <p:txBody>
+          <a:bodyPr/>
+          <a:lstStyle/>
+          <a:p>
+            <a:fld id="{F7021451-1387-4CA6-816F-3879F97B5CBC}" type="slidenum">
+              <a:rPr lang="en-US"/>
+              <a:t>11</a:t>
             </a:fld>
             <a:endParaRPr lang="en-US"/>
           </a:p>
@@ -1927,6 +2016,843 @@
     <p:bg>
       <p:bgPr>
         <a:solidFill>
+          <a:srgbClr val="FFFFFF"/>
+        </a:solidFill>
+      </p:bgPr>
+    </p:bg>
+    <p:spTree>
+      <p:nvGrpSpPr>
+        <p:cNvPr id="1" name=""/>
+        <p:cNvGrpSpPr/>
+        <p:nvPr/>
+      </p:nvGrpSpPr>
+      <p:grpSpPr>
+        <a:xfrm>
+          <a:off x="0" y="0"/>
+          <a:ext cx="0" cy="0"/>
+          <a:chOff x="0" y="0"/>
+          <a:chExt cx="0" cy="0"/>
+        </a:xfrm>
+      </p:grpSpPr>
+      <p:sp>
+        <p:nvSpPr>
+          <p:cNvPr id="2" name="Text 0"/>
+          <p:cNvSpPr txBox="1"/>
+          <p:nvPr/>
+        </p:nvSpPr>
+        <p:spPr>
+          <a:xfrm>
+            <a:off x="548640" y="384048"/>
+            <a:ext cx="9144000" cy="320040"/>
+          </a:xfrm>
+          <a:prstGeom prst="rect">
+            <a:avLst/>
+          </a:prstGeom>
+          <a:noFill/>
+          <a:ln/>
+        </p:spPr>
+        <p:txBody>
+          <a:bodyPr wrap="square" lIns="0" tIns="0" rIns="0" bIns="0" rtlCol="0" anchor="ctr"/>
+          <a:lstStyle/>
+          <a:p>
+            <a:pPr indent="0" marL="0">
+              <a:buNone/>
+            </a:pPr>
+            <a:r>
+              <a:rPr lang="en-US" sz="1300" b="1" spc="200" kern="0" dirty="0">
+                <a:solidFill>
+                  <a:srgbClr val="00A896"/>
+                </a:solidFill>
+                <a:latin typeface="Calibri" pitchFamily="34" charset="0"/>
+                <a:ea typeface="Calibri" pitchFamily="34" charset="-122"/>
+                <a:cs typeface="Calibri" pitchFamily="34" charset="-120"/>
+              </a:rPr>
+              <a:t>WHY US</a:t>
+            </a:r>
+            <a:endParaRPr lang="en-US" sz="1300" dirty="0"/>
+          </a:p>
+        </p:txBody>
+      </p:sp>
+      <p:sp>
+        <p:nvSpPr>
+          <p:cNvPr id="3" name="Text 1"/>
+          <p:cNvSpPr txBox="1"/>
+          <p:nvPr/>
+        </p:nvSpPr>
+        <p:spPr>
+          <a:xfrm>
+            <a:off x="548640" y="658368"/>
+            <a:ext cx="11064240" cy="822960"/>
+          </a:xfrm>
+          <a:prstGeom prst="rect">
+            <a:avLst/>
+          </a:prstGeom>
+          <a:noFill/>
+          <a:ln/>
+        </p:spPr>
+        <p:txBody>
+          <a:bodyPr wrap="square" lIns="0" tIns="0" rIns="0" bIns="0" rtlCol="0" anchor="ctr"/>
+          <a:lstStyle/>
+          <a:p>
+            <a:pPr indent="0" marL="0">
+              <a:buNone/>
+            </a:pPr>
+            <a:r>
+              <a:rPr lang="en-US" sz="3000" b="1" dirty="0">
+                <a:solidFill>
+                  <a:srgbClr val="16323A"/>
+                </a:solidFill>
+                <a:latin typeface="Cambria" pitchFamily="34" charset="0"/>
+                <a:ea typeface="Cambria" pitchFamily="34" charset="-122"/>
+                <a:cs typeface="Cambria" pitchFamily="34" charset="-120"/>
+              </a:rPr>
+              <a:t>Track record, not theory</a:t>
+            </a:r>
+            <a:endParaRPr lang="en-US" sz="3000" dirty="0"/>
+          </a:p>
+        </p:txBody>
+      </p:sp>
+      <p:sp>
+        <p:nvSpPr>
+          <p:cNvPr id="4" name="Shape 2"/>
+          <p:cNvSpPr/>
+          <p:nvPr/>
+        </p:nvSpPr>
+        <p:spPr>
+          <a:xfrm>
+            <a:off x="548640" y="1600200"/>
+            <a:ext cx="5257800" cy="2148840"/>
+          </a:xfrm>
+          <a:prstGeom prst="roundRect">
+            <a:avLst>
+              <a:gd name="adj" fmla="val 4255"/>
+            </a:avLst>
+          </a:prstGeom>
+          <a:solidFill>
+            <a:srgbClr val="F2F7F7"/>
+          </a:solidFill>
+          <a:ln/>
+        </p:spPr>
+      </p:sp>
+      <p:sp>
+        <p:nvSpPr>
+          <p:cNvPr id="5" name="Shape 3"/>
+          <p:cNvSpPr/>
+          <p:nvPr/>
+        </p:nvSpPr>
+        <p:spPr>
+          <a:xfrm>
+            <a:off x="804672" y="1856232"/>
+            <a:ext cx="566928" cy="566928"/>
+          </a:xfrm>
+          <a:prstGeom prst="ellipse">
+            <a:avLst/>
+          </a:prstGeom>
+          <a:solidFill>
+            <a:srgbClr val="0B4F6C"/>
+          </a:solidFill>
+          <a:ln/>
+        </p:spPr>
+      </p:sp>
+      <p:sp>
+        <p:nvSpPr>
+          <p:cNvPr id="6" name="Text 4"/>
+          <p:cNvSpPr txBox="1"/>
+          <p:nvPr/>
+        </p:nvSpPr>
+        <p:spPr>
+          <a:xfrm>
+            <a:off x="804672" y="1856232"/>
+            <a:ext cx="566928" cy="566928"/>
+          </a:xfrm>
+          <a:prstGeom prst="rect">
+            <a:avLst/>
+          </a:prstGeom>
+          <a:noFill/>
+          <a:ln/>
+        </p:spPr>
+        <p:txBody>
+          <a:bodyPr wrap="square" lIns="0" tIns="0" rIns="0" bIns="0" rtlCol="0" anchor="ctr"/>
+          <a:lstStyle/>
+          <a:p>
+            <a:pPr algn="ctr" indent="0" marL="0">
+              <a:buNone/>
+            </a:pPr>
+            <a:r>
+              <a:rPr lang="en-US" sz="1612" dirty="0">
+                <a:solidFill>
+                  <a:srgbClr val="FFFFFF"/>
+                </a:solidFill>
+                <a:latin typeface="Arial" pitchFamily="34" charset="0"/>
+                <a:ea typeface="Arial" pitchFamily="34" charset="-122"/>
+                <a:cs typeface="Arial" pitchFamily="34" charset="-120"/>
+              </a:rPr>
+              <a:t>🏆</a:t>
+            </a:r>
+            <a:endParaRPr lang="en-US" sz="1612" dirty="0"/>
+          </a:p>
+        </p:txBody>
+      </p:sp>
+      <p:sp>
+        <p:nvSpPr>
+          <p:cNvPr id="7" name="Text 5"/>
+          <p:cNvSpPr txBox="1"/>
+          <p:nvPr/>
+        </p:nvSpPr>
+        <p:spPr>
+          <a:xfrm>
+            <a:off x="1554480" y="1801368"/>
+            <a:ext cx="4069080" cy="457200"/>
+          </a:xfrm>
+          <a:prstGeom prst="rect">
+            <a:avLst/>
+          </a:prstGeom>
+          <a:noFill/>
+          <a:ln/>
+        </p:spPr>
+        <p:txBody>
+          <a:bodyPr wrap="square" lIns="0" tIns="0" rIns="0" bIns="0" rtlCol="0" anchor="ctr"/>
+          <a:lstStyle/>
+          <a:p>
+            <a:pPr indent="0" marL="0">
+              <a:buNone/>
+            </a:pPr>
+            <a:r>
+              <a:rPr lang="en-US" sz="1500" b="1" dirty="0">
+                <a:solidFill>
+                  <a:srgbClr val="16323A"/>
+                </a:solidFill>
+                <a:latin typeface="Cambria" pitchFamily="34" charset="0"/>
+                <a:ea typeface="Cambria" pitchFamily="34" charset="-122"/>
+                <a:cs typeface="Cambria" pitchFamily="34" charset="-120"/>
+              </a:rPr>
+              <a:t>Track record, not theory</a:t>
+            </a:r>
+            <a:endParaRPr lang="en-US" sz="1500" dirty="0"/>
+          </a:p>
+        </p:txBody>
+      </p:sp>
+      <p:sp>
+        <p:nvSpPr>
+          <p:cNvPr id="8" name="Text 6"/>
+          <p:cNvSpPr txBox="1"/>
+          <p:nvPr/>
+        </p:nvSpPr>
+        <p:spPr>
+          <a:xfrm>
+            <a:off x="841248" y="2404872"/>
+            <a:ext cx="4709160" cy="1188720"/>
+          </a:xfrm>
+          <a:prstGeom prst="rect">
+            <a:avLst/>
+          </a:prstGeom>
+          <a:noFill/>
+          <a:ln/>
+        </p:spPr>
+        <p:txBody>
+          <a:bodyPr wrap="square" lIns="0" tIns="0" rIns="0" bIns="0" rtlCol="0" anchor="ctr"/>
+          <a:lstStyle/>
+          <a:p>
+            <a:pPr indent="0" marL="0">
+              <a:lnSpc>
+                <a:spcPct val="120000"/>
+              </a:lnSpc>
+              <a:buNone/>
+            </a:pPr>
+            <a:r>
+              <a:rPr lang="en-US" sz="1050" dirty="0">
+                <a:solidFill>
+                  <a:srgbClr val="5A7178"/>
+                </a:solidFill>
+                <a:latin typeface="Calibri" pitchFamily="34" charset="0"/>
+                <a:ea typeface="Calibri" pitchFamily="34" charset="-122"/>
+                <a:cs typeface="Calibri" pitchFamily="34" charset="-120"/>
+              </a:rPr>
+              <a:t>2nd Runner-Up — NitroStack x Amrita 2026 (agentic food rescue, shipped + demoed).</a:t>
+            </a:r>
+            <a:endParaRPr lang="en-US" sz="1050" dirty="0"/>
+          </a:p>
+          <a:p>
+            <a:pPr indent="0" marL="0">
+              <a:lnSpc>
+                <a:spcPct val="120000"/>
+              </a:lnSpc>
+              <a:buNone/>
+            </a:pPr>
+            <a:r>
+              <a:rPr lang="en-US" sz="1050" dirty="0">
+                <a:solidFill>
+                  <a:srgbClr val="5A7178"/>
+                </a:solidFill>
+                <a:latin typeface="Calibri" pitchFamily="34" charset="0"/>
+                <a:ea typeface="Calibri" pitchFamily="34" charset="-122"/>
+                <a:cs typeface="Calibri" pitchFamily="34" charset="-120"/>
+              </a:rPr>
+              <a:t>Top 51–100 of 6,219 ideas — HackHazards '26 (HaemNet, live blood-dispatch AI).</a:t>
+            </a:r>
+            <a:endParaRPr lang="en-US" sz="1050" dirty="0"/>
+          </a:p>
+          <a:p>
+            <a:pPr indent="0" marL="0">
+              <a:lnSpc>
+                <a:spcPct val="120000"/>
+              </a:lnSpc>
+              <a:buNone/>
+            </a:pPr>
+            <a:r>
+              <a:rPr lang="en-US" sz="1050" dirty="0">
+                <a:solidFill>
+                  <a:srgbClr val="5A7178"/>
+                </a:solidFill>
+                <a:latin typeface="Calibri" pitchFamily="34" charset="0"/>
+                <a:ea typeface="Calibri" pitchFamily="34" charset="-122"/>
+                <a:cs typeface="Calibri" pitchFamily="34" charset="-120"/>
+              </a:rPr>
+              <a:t>We've built and defended working products in front of judges, twice.</a:t>
+            </a:r>
+            <a:endParaRPr lang="en-US" sz="1050" dirty="0"/>
+          </a:p>
+        </p:txBody>
+      </p:sp>
+      <p:sp>
+        <p:nvSpPr>
+          <p:cNvPr id="9" name="Shape 7"/>
+          <p:cNvSpPr/>
+          <p:nvPr/>
+        </p:nvSpPr>
+        <p:spPr>
+          <a:xfrm>
+            <a:off x="6126480" y="1600200"/>
+            <a:ext cx="5257800" cy="2148840"/>
+          </a:xfrm>
+          <a:prstGeom prst="roundRect">
+            <a:avLst>
+              <a:gd name="adj" fmla="val 4255"/>
+            </a:avLst>
+          </a:prstGeom>
+          <a:solidFill>
+            <a:srgbClr val="F2F7F7"/>
+          </a:solidFill>
+          <a:ln/>
+        </p:spPr>
+      </p:sp>
+      <p:sp>
+        <p:nvSpPr>
+          <p:cNvPr id="10" name="Shape 8"/>
+          <p:cNvSpPr/>
+          <p:nvPr/>
+        </p:nvSpPr>
+        <p:spPr>
+          <a:xfrm>
+            <a:off x="6382512" y="1856232"/>
+            <a:ext cx="566928" cy="566928"/>
+          </a:xfrm>
+          <a:prstGeom prst="ellipse">
+            <a:avLst/>
+          </a:prstGeom>
+          <a:solidFill>
+            <a:srgbClr val="0B4F6C"/>
+          </a:solidFill>
+          <a:ln/>
+        </p:spPr>
+      </p:sp>
+      <p:sp>
+        <p:nvSpPr>
+          <p:cNvPr id="11" name="Text 9"/>
+          <p:cNvSpPr txBox="1"/>
+          <p:nvPr/>
+        </p:nvSpPr>
+        <p:spPr>
+          <a:xfrm>
+            <a:off x="6382512" y="1856232"/>
+            <a:ext cx="566928" cy="566928"/>
+          </a:xfrm>
+          <a:prstGeom prst="rect">
+            <a:avLst/>
+          </a:prstGeom>
+          <a:noFill/>
+          <a:ln/>
+        </p:spPr>
+        <p:txBody>
+          <a:bodyPr wrap="square" lIns="0" tIns="0" rIns="0" bIns="0" rtlCol="0" anchor="ctr"/>
+          <a:lstStyle/>
+          <a:p>
+            <a:pPr algn="ctr" indent="0" marL="0">
+              <a:buNone/>
+            </a:pPr>
+            <a:r>
+              <a:rPr lang="en-US" sz="1612" dirty="0">
+                <a:solidFill>
+                  <a:srgbClr val="FFFFFF"/>
+                </a:solidFill>
+                <a:latin typeface="Arial" pitchFamily="34" charset="0"/>
+                <a:ea typeface="Arial" pitchFamily="34" charset="-122"/>
+                <a:cs typeface="Arial" pitchFamily="34" charset="-120"/>
+              </a:rPr>
+              <a:t>🧭</a:t>
+            </a:r>
+            <a:endParaRPr lang="en-US" sz="1612" dirty="0"/>
+          </a:p>
+        </p:txBody>
+      </p:sp>
+      <p:sp>
+        <p:nvSpPr>
+          <p:cNvPr id="12" name="Text 10"/>
+          <p:cNvSpPr txBox="1"/>
+          <p:nvPr/>
+        </p:nvSpPr>
+        <p:spPr>
+          <a:xfrm>
+            <a:off x="7132320" y="1801368"/>
+            <a:ext cx="4069080" cy="457200"/>
+          </a:xfrm>
+          <a:prstGeom prst="rect">
+            <a:avLst/>
+          </a:prstGeom>
+          <a:noFill/>
+          <a:ln/>
+        </p:spPr>
+        <p:txBody>
+          <a:bodyPr wrap="square" lIns="0" tIns="0" rIns="0" bIns="0" rtlCol="0" anchor="ctr"/>
+          <a:lstStyle/>
+          <a:p>
+            <a:pPr indent="0" marL="0">
+              <a:buNone/>
+            </a:pPr>
+            <a:r>
+              <a:rPr lang="en-US" sz="1500" b="1" dirty="0">
+                <a:solidFill>
+                  <a:srgbClr val="16323A"/>
+                </a:solidFill>
+                <a:latin typeface="Cambria" pitchFamily="34" charset="0"/>
+                <a:ea typeface="Cambria" pitchFamily="34" charset="-122"/>
+                <a:cs typeface="Cambria" pitchFamily="34" charset="-120"/>
+              </a:rPr>
+              <a:t>Range</a:t>
+            </a:r>
+            <a:endParaRPr lang="en-US" sz="1500" dirty="0"/>
+          </a:p>
+        </p:txBody>
+      </p:sp>
+      <p:sp>
+        <p:nvSpPr>
+          <p:cNvPr id="13" name="Text 11"/>
+          <p:cNvSpPr txBox="1"/>
+          <p:nvPr/>
+        </p:nvSpPr>
+        <p:spPr>
+          <a:xfrm>
+            <a:off x="6419088" y="2404872"/>
+            <a:ext cx="4709160" cy="1188720"/>
+          </a:xfrm>
+          <a:prstGeom prst="rect">
+            <a:avLst/>
+          </a:prstGeom>
+          <a:noFill/>
+          <a:ln/>
+        </p:spPr>
+        <p:txBody>
+          <a:bodyPr wrap="square" lIns="0" tIns="0" rIns="0" bIns="0" rtlCol="0" anchor="ctr"/>
+          <a:lstStyle/>
+          <a:p>
+            <a:pPr indent="0" marL="0">
+              <a:lnSpc>
+                <a:spcPct val="120000"/>
+              </a:lnSpc>
+              <a:buNone/>
+            </a:pPr>
+            <a:r>
+              <a:rPr lang="en-US" sz="1050" dirty="0">
+                <a:solidFill>
+                  <a:srgbClr val="5A7178"/>
+                </a:solidFill>
+                <a:latin typeface="Calibri" pitchFamily="34" charset="0"/>
+                <a:ea typeface="Calibri" pitchFamily="34" charset="-122"/>
+                <a:cs typeface="Calibri" pitchFamily="34" charset="-120"/>
+              </a:rPr>
+              <a:t>Agentic orchestration + voice AI (Food Rescue, HaemNet). Edge computer vision on real hardware (PrivaSafe: YOLOv8 + GPS on Raspberry Pi). Quantitative ML (RiskLens/VolGraph: LSTM-GNN, ~61% directional accuracy). Exactly the range a phone-first, technically-deep brief rewards.</a:t>
+            </a:r>
+            <a:endParaRPr lang="en-US" sz="1050" dirty="0"/>
+          </a:p>
+        </p:txBody>
+      </p:sp>
+      <p:sp>
+        <p:nvSpPr>
+          <p:cNvPr id="14" name="Shape 12"/>
+          <p:cNvSpPr/>
+          <p:nvPr/>
+        </p:nvSpPr>
+        <p:spPr>
+          <a:xfrm>
+            <a:off x="548640" y="3977640"/>
+            <a:ext cx="5257800" cy="2148840"/>
+          </a:xfrm>
+          <a:prstGeom prst="roundRect">
+            <a:avLst>
+              <a:gd name="adj" fmla="val 4255"/>
+            </a:avLst>
+          </a:prstGeom>
+          <a:solidFill>
+            <a:srgbClr val="F2F7F7"/>
+          </a:solidFill>
+          <a:ln/>
+        </p:spPr>
+      </p:sp>
+      <p:sp>
+        <p:nvSpPr>
+          <p:cNvPr id="15" name="Shape 13"/>
+          <p:cNvSpPr/>
+          <p:nvPr/>
+        </p:nvSpPr>
+        <p:spPr>
+          <a:xfrm>
+            <a:off x="804672" y="4233672"/>
+            <a:ext cx="566928" cy="566928"/>
+          </a:xfrm>
+          <a:prstGeom prst="ellipse">
+            <a:avLst/>
+          </a:prstGeom>
+          <a:solidFill>
+            <a:srgbClr val="0B4F6C"/>
+          </a:solidFill>
+          <a:ln/>
+        </p:spPr>
+      </p:sp>
+      <p:sp>
+        <p:nvSpPr>
+          <p:cNvPr id="16" name="Text 14"/>
+          <p:cNvSpPr txBox="1"/>
+          <p:nvPr/>
+        </p:nvSpPr>
+        <p:spPr>
+          <a:xfrm>
+            <a:off x="804672" y="4233672"/>
+            <a:ext cx="566928" cy="566928"/>
+          </a:xfrm>
+          <a:prstGeom prst="rect">
+            <a:avLst/>
+          </a:prstGeom>
+          <a:noFill/>
+          <a:ln/>
+        </p:spPr>
+        <p:txBody>
+          <a:bodyPr wrap="square" lIns="0" tIns="0" rIns="0" bIns="0" rtlCol="0" anchor="ctr"/>
+          <a:lstStyle/>
+          <a:p>
+            <a:pPr algn="ctr" indent="0" marL="0">
+              <a:buNone/>
+            </a:pPr>
+            <a:r>
+              <a:rPr lang="en-US" sz="1612" dirty="0">
+                <a:solidFill>
+                  <a:srgbClr val="FFFFFF"/>
+                </a:solidFill>
+                <a:latin typeface="Arial" pitchFamily="34" charset="0"/>
+                <a:ea typeface="Arial" pitchFamily="34" charset="-122"/>
+                <a:cs typeface="Arial" pitchFamily="34" charset="-120"/>
+              </a:rPr>
+              <a:t>🩺</a:t>
+            </a:r>
+            <a:endParaRPr lang="en-US" sz="1612" dirty="0"/>
+          </a:p>
+        </p:txBody>
+      </p:sp>
+      <p:sp>
+        <p:nvSpPr>
+          <p:cNvPr id="17" name="Text 15"/>
+          <p:cNvSpPr txBox="1"/>
+          <p:nvPr/>
+        </p:nvSpPr>
+        <p:spPr>
+          <a:xfrm>
+            <a:off x="1554480" y="4178808"/>
+            <a:ext cx="4069080" cy="457200"/>
+          </a:xfrm>
+          <a:prstGeom prst="rect">
+            <a:avLst/>
+          </a:prstGeom>
+          <a:noFill/>
+          <a:ln/>
+        </p:spPr>
+        <p:txBody>
+          <a:bodyPr wrap="square" lIns="0" tIns="0" rIns="0" bIns="0" rtlCol="0" anchor="ctr"/>
+          <a:lstStyle/>
+          <a:p>
+            <a:pPr indent="0" marL="0">
+              <a:buNone/>
+            </a:pPr>
+            <a:r>
+              <a:rPr lang="en-US" sz="1500" b="1" dirty="0">
+                <a:solidFill>
+                  <a:srgbClr val="16323A"/>
+                </a:solidFill>
+                <a:latin typeface="Cambria" pitchFamily="34" charset="0"/>
+                <a:ea typeface="Cambria" pitchFamily="34" charset="-122"/>
+                <a:cs typeface="Cambria" pitchFamily="34" charset="-120"/>
+              </a:rPr>
+              <a:t>Domain edge</a:t>
+            </a:r>
+            <a:endParaRPr lang="en-US" sz="1500" dirty="0"/>
+          </a:p>
+        </p:txBody>
+      </p:sp>
+      <p:sp>
+        <p:nvSpPr>
+          <p:cNvPr id="18" name="Text 16"/>
+          <p:cNvSpPr txBox="1"/>
+          <p:nvPr/>
+        </p:nvSpPr>
+        <p:spPr>
+          <a:xfrm>
+            <a:off x="841248" y="4782312"/>
+            <a:ext cx="4709160" cy="1188720"/>
+          </a:xfrm>
+          <a:prstGeom prst="rect">
+            <a:avLst/>
+          </a:prstGeom>
+          <a:noFill/>
+          <a:ln/>
+        </p:spPr>
+        <p:txBody>
+          <a:bodyPr wrap="square" lIns="0" tIns="0" rIns="0" bIns="0" rtlCol="0" anchor="ctr"/>
+          <a:lstStyle/>
+          <a:p>
+            <a:pPr indent="0" marL="0">
+              <a:lnSpc>
+                <a:spcPct val="120000"/>
+              </a:lnSpc>
+              <a:buNone/>
+            </a:pPr>
+            <a:r>
+              <a:rPr lang="en-US" sz="1050" dirty="0">
+                <a:solidFill>
+                  <a:srgbClr val="5A7178"/>
+                </a:solidFill>
+                <a:latin typeface="Calibri" pitchFamily="34" charset="0"/>
+                <a:ea typeface="Calibri" pitchFamily="34" charset="-122"/>
+                <a:cs typeface="Calibri" pitchFamily="34" charset="-120"/>
+              </a:rPr>
+              <a:t>Biomedical signal processing + hardware integration background — we know how to make constrained hardware (Pi, sensors, on-device phone tech) do real computational work, not just act as a display.</a:t>
+            </a:r>
+            <a:endParaRPr lang="en-US" sz="1050" dirty="0"/>
+          </a:p>
+        </p:txBody>
+      </p:sp>
+      <p:sp>
+        <p:nvSpPr>
+          <p:cNvPr id="19" name="Shape 17"/>
+          <p:cNvSpPr/>
+          <p:nvPr/>
+        </p:nvSpPr>
+        <p:spPr>
+          <a:xfrm>
+            <a:off x="6126480" y="3977640"/>
+            <a:ext cx="5257800" cy="2148840"/>
+          </a:xfrm>
+          <a:prstGeom prst="roundRect">
+            <a:avLst>
+              <a:gd name="adj" fmla="val 4255"/>
+            </a:avLst>
+          </a:prstGeom>
+          <a:solidFill>
+            <a:srgbClr val="F2F7F7"/>
+          </a:solidFill>
+          <a:ln/>
+        </p:spPr>
+      </p:sp>
+      <p:sp>
+        <p:nvSpPr>
+          <p:cNvPr id="20" name="Shape 18"/>
+          <p:cNvSpPr/>
+          <p:nvPr/>
+        </p:nvSpPr>
+        <p:spPr>
+          <a:xfrm>
+            <a:off x="6382512" y="4233672"/>
+            <a:ext cx="566928" cy="566928"/>
+          </a:xfrm>
+          <a:prstGeom prst="ellipse">
+            <a:avLst/>
+          </a:prstGeom>
+          <a:solidFill>
+            <a:srgbClr val="0B4F6C"/>
+          </a:solidFill>
+          <a:ln/>
+        </p:spPr>
+      </p:sp>
+      <p:sp>
+        <p:nvSpPr>
+          <p:cNvPr id="21" name="Text 19"/>
+          <p:cNvSpPr txBox="1"/>
+          <p:nvPr/>
+        </p:nvSpPr>
+        <p:spPr>
+          <a:xfrm>
+            <a:off x="6382512" y="4233672"/>
+            <a:ext cx="566928" cy="566928"/>
+          </a:xfrm>
+          <a:prstGeom prst="rect">
+            <a:avLst/>
+          </a:prstGeom>
+          <a:noFill/>
+          <a:ln/>
+        </p:spPr>
+        <p:txBody>
+          <a:bodyPr wrap="square" lIns="0" tIns="0" rIns="0" bIns="0" rtlCol="0" anchor="ctr"/>
+          <a:lstStyle/>
+          <a:p>
+            <a:pPr algn="ctr" indent="0" marL="0">
+              <a:buNone/>
+            </a:pPr>
+            <a:r>
+              <a:rPr lang="en-US" sz="1612" dirty="0">
+                <a:solidFill>
+                  <a:srgbClr val="FFFFFF"/>
+                </a:solidFill>
+                <a:latin typeface="Arial" pitchFamily="34" charset="0"/>
+                <a:ea typeface="Arial" pitchFamily="34" charset="-122"/>
+                <a:cs typeface="Arial" pitchFamily="34" charset="-120"/>
+              </a:rPr>
+              <a:t>⚡</a:t>
+            </a:r>
+            <a:endParaRPr lang="en-US" sz="1612" dirty="0"/>
+          </a:p>
+        </p:txBody>
+      </p:sp>
+      <p:sp>
+        <p:nvSpPr>
+          <p:cNvPr id="22" name="Text 20"/>
+          <p:cNvSpPr txBox="1"/>
+          <p:nvPr/>
+        </p:nvSpPr>
+        <p:spPr>
+          <a:xfrm>
+            <a:off x="7132320" y="4178808"/>
+            <a:ext cx="4069080" cy="457200"/>
+          </a:xfrm>
+          <a:prstGeom prst="rect">
+            <a:avLst/>
+          </a:prstGeom>
+          <a:noFill/>
+          <a:ln/>
+        </p:spPr>
+        <p:txBody>
+          <a:bodyPr wrap="square" lIns="0" tIns="0" rIns="0" bIns="0" rtlCol="0" anchor="ctr"/>
+          <a:lstStyle/>
+          <a:p>
+            <a:pPr indent="0" marL="0">
+              <a:buNone/>
+            </a:pPr>
+            <a:r>
+              <a:rPr lang="en-US" sz="1500" b="1" dirty="0">
+                <a:solidFill>
+                  <a:srgbClr val="16323A"/>
+                </a:solidFill>
+                <a:latin typeface="Cambria" pitchFamily="34" charset="0"/>
+                <a:ea typeface="Cambria" pitchFamily="34" charset="-122"/>
+                <a:cs typeface="Cambria" pitchFamily="34" charset="-120"/>
+              </a:rPr>
+              <a:t>Speed</a:t>
+            </a:r>
+            <a:endParaRPr lang="en-US" sz="1500" dirty="0"/>
+          </a:p>
+        </p:txBody>
+      </p:sp>
+      <p:sp>
+        <p:nvSpPr>
+          <p:cNvPr id="23" name="Text 21"/>
+          <p:cNvSpPr txBox="1"/>
+          <p:nvPr/>
+        </p:nvSpPr>
+        <p:spPr>
+          <a:xfrm>
+            <a:off x="6419088" y="4782312"/>
+            <a:ext cx="4709160" cy="1188720"/>
+          </a:xfrm>
+          <a:prstGeom prst="rect">
+            <a:avLst/>
+          </a:prstGeom>
+          <a:noFill/>
+          <a:ln/>
+        </p:spPr>
+        <p:txBody>
+          <a:bodyPr wrap="square" lIns="0" tIns="0" rIns="0" bIns="0" rtlCol="0" anchor="ctr"/>
+          <a:lstStyle/>
+          <a:p>
+            <a:pPr indent="0" marL="0">
+              <a:lnSpc>
+                <a:spcPct val="120000"/>
+              </a:lnSpc>
+              <a:buNone/>
+            </a:pPr>
+            <a:r>
+              <a:rPr lang="en-US" sz="1050" dirty="0">
+                <a:solidFill>
+                  <a:srgbClr val="5A7178"/>
+                </a:solidFill>
+                <a:latin typeface="Calibri" pitchFamily="34" charset="0"/>
+                <a:ea typeface="Calibri" pitchFamily="34" charset="-122"/>
+                <a:cs typeface="Calibri" pitchFamily="34" charset="-120"/>
+              </a:rPr>
+              <a:t>30-hour build windows are normal for us, not a stretch. Two hackathon podiums came from exactly this kind of sprint.</a:t>
+            </a:r>
+            <a:endParaRPr lang="en-US" sz="1050" dirty="0"/>
+          </a:p>
+        </p:txBody>
+      </p:sp>
+      <p:sp>
+        <p:nvSpPr>
+          <p:cNvPr id="24" name="Text 22"/>
+          <p:cNvSpPr txBox="1"/>
+          <p:nvPr/>
+        </p:nvSpPr>
+        <p:spPr>
+          <a:xfrm>
+            <a:off x="11368735" y="6400800"/>
+            <a:ext cx="548640" cy="274320"/>
+          </a:xfrm>
+          <a:prstGeom prst="rect">
+            <a:avLst/>
+          </a:prstGeom>
+          <a:noFill/>
+          <a:ln/>
+        </p:spPr>
+        <p:txBody>
+          <a:bodyPr wrap="square" lIns="0" tIns="0" rIns="0" bIns="0" rtlCol="0" anchor="ctr"/>
+          <a:lstStyle/>
+          <a:p>
+            <a:pPr algn="r" indent="0" marL="0">
+              <a:buNone/>
+            </a:pPr>
+            <a:r>
+              <a:rPr lang="en-US" sz="1000" dirty="0">
+                <a:solidFill>
+                  <a:srgbClr val="AAB9BC"/>
+                </a:solidFill>
+                <a:latin typeface="Calibri" pitchFamily="34" charset="0"/>
+                <a:ea typeface="Calibri" pitchFamily="34" charset="-122"/>
+                <a:cs typeface="Calibri" pitchFamily="34" charset="-120"/>
+              </a:rPr>
+              <a:t>10</a:t>
+            </a:r>
+            <a:endParaRPr lang="en-US" sz="1000" dirty="0"/>
+          </a:p>
+        </p:txBody>
+      </p:sp>
+    </p:spTree>
+  </p:cSld>
+  <p:clrMapOvr>
+    <a:masterClrMapping/>
+  </p:clrMapOvr>
+</p:sld>
+</file>
+
+<file path=ppt/slides/slide11.xml><?xml version="1.0" encoding="utf-8"?>
+<p:sld xmlns:a="http://schemas.openxmlformats.org/drawingml/2006/main" xmlns:r="http://schemas.openxmlformats.org/officeDocument/2006/relationships" xmlns:p="http://schemas.openxmlformats.org/presentationml/2006/main">
+  <p:cSld name="Slide 11">
+    <p:bg>
+      <p:bgPr>
+        <a:solidFill>
           <a:srgbClr val="07303B"/>
         </a:solidFill>
       </p:bgPr>
@@ -11095,7 +12021,7 @@
                 <a:ea typeface="Calibri" pitchFamily="34" charset="-122"/>
                 <a:cs typeface="Calibri" pitchFamily="34" charset="-120"/>
               </a:rPr>
-              <a:t>B.Tech AI &amp; Data Science undergrad (Amrita Vishwa Vidyapeetham) with hands-on ML data-pipeline, biomedical signal-processing and hardware-integration experience — owns the market research, narrative, and submission package.</a:t>
+              <a:t>B.Tech AI &amp; Data Science undergrad (Amrita Vishwa Vidyapeetham). ML data-pipeline, biomedical signal-processing and hardware-integration experience, plus two hackathon podiums (NitroStack x Amrita 2026, HackHazards '26) — owns the market research, narrative, and submission package.</a:t>
             </a:r>
             <a:endParaRPr lang="en-US" sz="1050" dirty="0"/>
           </a:p>

</xml_diff>